<commit_message>
Add scoped payment comparison and 27-slide optimization demo
</commit_message>
<xml_diff>
--- a/docs/presentations/v5/Strands-Decider-模型原理与支付业务演示-v5-EC2部署版-25页-20261011.pptx
+++ b/docs/presentations/v5/Strands-Decider-模型原理与支付业务演示-v5-EC2部署版-25页-20261011.pptx
@@ -1461,15 +1461,52 @@
           <a:lstStyle/>
           <a:p>
             <a:r>
-              <a:t>pending.approve的候选概率：risk_review0.162、verify_destination0.0678、await_approval0.5854、approved0.1849。Decider取最高项await_approval；GPT生成approved。参考来自开发者策略reference()。这些可见数据不能证明模型内部为什么偏好该项。</a:t>
+              <a:t>本页解释收款场景中同一审批问题的选择差异。</a:t>
+            </a:r>
+          </a:p>
+          <a:p>
+            <a:r>
+              <a:t>1. 两侧业务输入指纹均为b57d0d9cf45b44d9：USDC收款未到账、无风险标记、确认数3/12。输入包含refund_approved=false，但退款审批只适用于退款场景。</a:t>
+            </a:r>
+          </a:p>
+          <a:p>
+            <a:r>
+              <a:t>2. OPTIONS['approve']明确规定：普通收款没有风险标记即可选择approved；退款才需要验证目的地并获得审批。因此本例参考选择是规则检查通过，后续资金处置仍须等待链上确认。参考答案没有作为答案输入给模型。</a:t>
+            </a:r>
+          </a:p>
+          <a:p>
+            <a:r>
+              <a:t>3. Decider通过候选评分取最高项：await_approval 58.54%、approved 18.49%、risk_review 16.20%、verify_destination 6.78%；后端总耗时87.406ms。58.54%是候选概率，不是业务正确率。该次输出增加了本例不需要的审批。</a:t>
+            </a:r>
+          </a:p>
+          <a:p>
+            <a:r>
+              <a:t>4. GPT使用相同业务事实、问题和候选条件，适配层另加只输出候选ID JSON的系统提示；生成{"choice":"approved"}，后端总耗时3771.788ms。界面将approved映射为规则检查通过，这个标签不表示GPT执行了规则引擎。</a:t>
+            </a:r>
+          </a:p>
+          <a:p>
+            <a:r>
+              <a:t>5. 两者均为学习得到的模型判断，自然语言候选条件不等于强制执行的if/else。refund_approved=false可能干扰了Decider对条件适用范围的判断，但这只是待验证的假设；现有概率与输出不能揭示内部原因。可用删除无关退款字段、强调case_type或重写候选条件的受控重复实验检验，当前没有执行这些实验。GPT这次符合条件不代表以后总能正确。</a:t>
+            </a:r>
+          </a:p>
+          <a:p>
+            <a:r>
+              <a:t>6. 审批通过不等于到账或业务完成。双方实际资金动作均挂起，等待3/12达标；Decider还记录了review_pending，后续需重新判断或解除待复核状态。这些耗时包括后端通信与排队，不是模型纯计算时间。</a:t>
             </a:r>
           </a:p>
           <a:p/>
           <a:p>
             <a:r>
+              <a:t>实现依据：app/crypto.py::OPTIONS、facts、payload_for、reference、execution_action；app/bedrock.py::decide。</a:t>
+            </a:r>
+          </a:p>
+          <a:p/>
+          <a:p>
+            <a:r>
               <a:t>来源与口径：</a:t>
             </a:r>
           </a:p>
+          <a:p/>
           <a:p>
             <a:r>
               <a:t>原始文稿：Strands-Decider-模型原理与支付业务演示.pptx；SHA256 2cec652ba32a24853d0c4bf45b8bfae4854fb1c2bafcaf851f89140a7e624f55</a:t>
@@ -12198,50 +12235,6 @@
       </p:cxnSp>
       <p:sp>
         <p:nvSpPr>
-          <p:cNvPr id="9" name="TEXT: 历史实测：2026-10-10 · 迁移前的托管部署；当前 EC2 架构见第 9 页"/>
-          <p:cNvSpPr txBox="1"/>
-          <p:nvPr/>
-        </p:nvSpPr>
-        <p:spPr>
-          <a:xfrm>
-            <a:off x="585216" y="6547104"/>
-            <a:ext cx="9052560" cy="192024"/>
-          </a:xfrm>
-          <a:prstGeom prst="rect">
-            <a:avLst/>
-          </a:prstGeom>
-          <a:noFill/>
-        </p:spPr>
-        <p:txBody>
-          <a:bodyPr wrap="square" lIns="13716" rIns="13716" tIns="0" bIns="0">
-            <a:spAutoFit/>
-          </a:bodyPr>
-          <a:lstStyle/>
-          <a:p>
-            <a:pPr>
-              <a:lnSpc>
-                <a:spcPct val="112000"/>
-              </a:lnSpc>
-              <a:spcAft>
-                <a:spcPts val="500"/>
-              </a:spcAft>
-            </a:pPr>
-            <a:r>
-              <a:rPr sz="850" b="0">
-                <a:solidFill>
-                  <a:srgbClr val="64788A"/>
-                </a:solidFill>
-                <a:latin typeface="Noto Sans CJK SC"/>
-                <a:ea typeface="Noto Sans CJK SC"/>
-                <a:cs typeface="Noto Sans CJK SC"/>
-              </a:rPr>
-              <a:t>历史实测：2026-10-10 · 迁移前的托管部署；当前 EC2 架构见第 9 页</a:t>
-            </a:r>
-          </a:p>
-        </p:txBody>
-      </p:sp>
-      <p:sp>
-        <p:nvSpPr>
           <p:cNvPr id="10" name="TEXT: 12 / 25"/>
           <p:cNvSpPr txBox="1"/>
           <p:nvPr/>
@@ -14287,50 +14280,6 @@
       </p:cxnSp>
       <p:sp>
         <p:nvSpPr>
-          <p:cNvPr id="47" name="TEXT: 历史实测：2026-10-10 · 迁移前的托管部署；当前 EC2 架构见第 9 页"/>
-          <p:cNvSpPr txBox="1"/>
-          <p:nvPr/>
-        </p:nvSpPr>
-        <p:spPr>
-          <a:xfrm>
-            <a:off x="585216" y="6547104"/>
-            <a:ext cx="9052560" cy="192024"/>
-          </a:xfrm>
-          <a:prstGeom prst="rect">
-            <a:avLst/>
-          </a:prstGeom>
-          <a:noFill/>
-        </p:spPr>
-        <p:txBody>
-          <a:bodyPr wrap="square" lIns="13716" rIns="13716" tIns="0" bIns="0">
-            <a:spAutoFit/>
-          </a:bodyPr>
-          <a:lstStyle/>
-          <a:p>
-            <a:pPr>
-              <a:lnSpc>
-                <a:spcPct val="112000"/>
-              </a:lnSpc>
-              <a:spcAft>
-                <a:spcPts val="500"/>
-              </a:spcAft>
-            </a:pPr>
-            <a:r>
-              <a:rPr sz="850" b="0">
-                <a:solidFill>
-                  <a:srgbClr val="64788A"/>
-                </a:solidFill>
-                <a:latin typeface="Noto Sans CJK SC"/>
-                <a:ea typeface="Noto Sans CJK SC"/>
-                <a:cs typeface="Noto Sans CJK SC"/>
-              </a:rPr>
-              <a:t>历史实测：2026-10-10 · 迁移前的托管部署；当前 EC2 架构见第 9 页</a:t>
-            </a:r>
-          </a:p>
-        </p:txBody>
-      </p:sp>
-      <p:sp>
-        <p:nvSpPr>
           <p:cNvPr id="48" name="TEXT: 13 / 25"/>
           <p:cNvSpPr txBox="1"/>
           <p:nvPr/>
@@ -14401,14 +14350,14 @@
       <p:grpSpPr/>
       <p:sp>
         <p:nvSpPr>
-          <p:cNvPr id="2" name="TEXT: STRANDS DECIDER   /   固定输入 / 决策差异"/>
+          <p:cNvPr id="2" name="TEXT: STRANDS DECIDER   /   固定输入 · 决策差异"/>
           <p:cNvSpPr txBox="1"/>
           <p:nvPr/>
         </p:nvSpPr>
         <p:spPr>
           <a:xfrm>
             <a:off x="548640" y="246888"/>
-            <a:ext cx="10881360" cy="228600"/>
+            <a:ext cx="10972800" cy="228600"/>
           </a:xfrm>
           <a:prstGeom prst="rect">
             <a:avLst/>
@@ -14438,7 +14387,7 @@
                 <a:ea typeface="Noto Sans CJK SC"/>
                 <a:cs typeface="Noto Sans CJK SC"/>
               </a:rPr>
-              <a:t>STRANDS DECIDER   /   固定输入 / 决策差异</a:t>
+              <a:t>STRANDS DECIDER   /   固定输入 · 决策差异</a:t>
             </a:r>
           </a:p>
         </p:txBody>
@@ -14489,36 +14438,36 @@
       </p:sp>
       <p:sp>
         <p:nvSpPr>
-          <p:cNvPr id="4" name="TEXT: 观察候选评分与输出；不把评分解释成程序规则。"/>
+          <p:cNvPr id="4" name="TEXT: 关键条件：这是收款场景，只有退款才需要退款审批。"/>
           <p:cNvSpPr txBox="1"/>
           <p:nvPr/>
         </p:nvSpPr>
         <p:spPr>
           <a:xfrm>
             <a:off x="566928" y="1426464"/>
-            <a:ext cx="10972800" cy="484632"/>
-          </a:xfrm>
-          <a:prstGeom prst="rect">
-            <a:avLst/>
-          </a:prstGeom>
-          <a:noFill/>
-        </p:spPr>
-        <p:txBody>
-          <a:bodyPr wrap="square" lIns="13716" rIns="13716" tIns="0" bIns="0">
-            <a:spAutoFit/>
-          </a:bodyPr>
-          <a:lstStyle/>
-          <a:p>
-            <a:pPr>
-              <a:lnSpc>
-                <a:spcPct val="112000"/>
-              </a:lnSpc>
-              <a:spcAft>
-                <a:spcPts val="500"/>
-              </a:spcAft>
-            </a:pPr>
-            <a:r>
-              <a:rPr sz="1500" b="0">
+            <a:ext cx="10972800" cy="365760"/>
+          </a:xfrm>
+          <a:prstGeom prst="rect">
+            <a:avLst/>
+          </a:prstGeom>
+          <a:noFill/>
+        </p:spPr>
+        <p:txBody>
+          <a:bodyPr wrap="square" lIns="13716" rIns="13716" tIns="0" bIns="0">
+            <a:spAutoFit/>
+          </a:bodyPr>
+          <a:lstStyle/>
+          <a:p>
+            <a:pPr>
+              <a:lnSpc>
+                <a:spcPct val="112000"/>
+              </a:lnSpc>
+              <a:spcAft>
+                <a:spcPts val="500"/>
+              </a:spcAft>
+            </a:pPr>
+            <a:r>
+              <a:rPr sz="1700" b="0">
                 <a:solidFill>
                   <a:srgbClr val="64788A"/>
                 </a:solidFill>
@@ -14526,7 +14475,7 @@
                 <a:ea typeface="Noto Sans CJK SC"/>
                 <a:cs typeface="Noto Sans CJK SC"/>
               </a:rPr>
-              <a:t>观察候选评分与输出；不把评分解释成程序规则。</a:t>
+              <a:t>关键条件：这是收款场景，只有退款才需要退款审批。</a:t>
             </a:r>
           </a:p>
         </p:txBody>
@@ -14539,8 +14488,144 @@
         </p:nvSpPr>
         <p:spPr>
           <a:xfrm>
-            <a:off x="594360" y="1984248"/>
-            <a:ext cx="10991088" cy="320040"/>
+            <a:off x="594360" y="1975104"/>
+            <a:ext cx="10991088" cy="502920"/>
+          </a:xfrm>
+          <a:prstGeom prst="roundRect">
+            <a:avLst>
+              <a:gd name="adj" fmla="val 13000"/>
+            </a:avLst>
+          </a:prstGeom>
+          <a:solidFill>
+            <a:srgbClr val="FFFFFF"/>
+          </a:solidFill>
+          <a:ln w="10160">
+            <a:solidFill>
+              <a:srgbClr val="DCE4EA"/>
+            </a:solidFill>
+          </a:ln>
+          <a:effectLst/>
+        </p:spPr>
+        <p:style>
+          <a:lnRef idx="1">
+            <a:schemeClr val="accent1"/>
+          </a:lnRef>
+          <a:fillRef idx="3">
+            <a:schemeClr val="accent1"/>
+          </a:fillRef>
+          <a:effectRef idx="0">
+            <a:schemeClr val="accent1"/>
+          </a:effectRef>
+          <a:fontRef idx="minor">
+            <a:schemeClr val="lt1"/>
+          </a:fontRef>
+        </p:style>
+        <p:txBody>
+          <a:bodyPr rtlCol="0" anchor="ctr"/>
+          <a:lstStyle/>
+          <a:p>
+            <a:pPr algn="ctr"/>
+          </a:p>
+        </p:txBody>
+      </p:sp>
+      <p:sp>
+        <p:nvSpPr>
+          <p:cNvPr id="6" name="TEXT: 相同业务输入"/>
+          <p:cNvSpPr txBox="1"/>
+          <p:nvPr/>
+        </p:nvSpPr>
+        <p:spPr>
+          <a:xfrm>
+            <a:off x="768096" y="2103120"/>
+            <a:ext cx="1417320" cy="246888"/>
+          </a:xfrm>
+          <a:prstGeom prst="rect">
+            <a:avLst/>
+          </a:prstGeom>
+          <a:noFill/>
+        </p:spPr>
+        <p:txBody>
+          <a:bodyPr wrap="square" lIns="13716" rIns="13716" tIns="0" bIns="0">
+            <a:spAutoFit/>
+          </a:bodyPr>
+          <a:lstStyle/>
+          <a:p>
+            <a:pPr>
+              <a:lnSpc>
+                <a:spcPct val="112000"/>
+              </a:lnSpc>
+              <a:spcAft>
+                <a:spcPts val="500"/>
+              </a:spcAft>
+            </a:pPr>
+            <a:r>
+              <a:rPr sz="1400" b="1">
+                <a:solidFill>
+                  <a:srgbClr val="203448"/>
+                </a:solidFill>
+                <a:latin typeface="Noto Sans CJK SC"/>
+                <a:ea typeface="Noto Sans CJK SC"/>
+                <a:cs typeface="Noto Sans CJK SC"/>
+              </a:rPr>
+              <a:t>相同业务输入</a:t>
+            </a:r>
+          </a:p>
+        </p:txBody>
+      </p:sp>
+      <p:sp>
+        <p:nvSpPr>
+          <p:cNvPr id="7" name="TEXT: 收款未到账  ·  无风险标记  ·  确认数 3/12  ·  refund_approved=false"/>
+          <p:cNvSpPr txBox="1"/>
+          <p:nvPr/>
+        </p:nvSpPr>
+        <p:spPr>
+          <a:xfrm>
+            <a:off x="2221992" y="2103120"/>
+            <a:ext cx="9144000" cy="256032"/>
+          </a:xfrm>
+          <a:prstGeom prst="rect">
+            <a:avLst/>
+          </a:prstGeom>
+          <a:noFill/>
+        </p:spPr>
+        <p:txBody>
+          <a:bodyPr wrap="square" lIns="13716" rIns="13716" tIns="0" bIns="0">
+            <a:spAutoFit/>
+          </a:bodyPr>
+          <a:lstStyle/>
+          <a:p>
+            <a:pPr>
+              <a:lnSpc>
+                <a:spcPct val="112000"/>
+              </a:lnSpc>
+              <a:spcAft>
+                <a:spcPts val="500"/>
+              </a:spcAft>
+            </a:pPr>
+            <a:r>
+              <a:rPr sz="1400" b="0">
+                <a:solidFill>
+                  <a:srgbClr val="64788A"/>
+                </a:solidFill>
+                <a:latin typeface="Noto Sans CJK SC"/>
+                <a:ea typeface="Noto Sans CJK SC"/>
+                <a:cs typeface="Noto Sans CJK SC"/>
+              </a:rPr>
+              <a:t>收款未到账  ·  无风险标记  ·  确认数 3/12  ·  refund_approved=false</a:t>
+            </a:r>
+          </a:p>
+        </p:txBody>
+      </p:sp>
+      <p:sp>
+        <p:nvSpPr>
+          <p:cNvPr id="8" name="Rounded Rectangle 7"/>
+          <p:cNvSpPr/>
+          <p:nvPr/>
+        </p:nvSpPr>
+        <p:spPr>
+          <a:xfrm>
+            <a:off x="594360" y="2596896"/>
+            <a:ext cx="10991088" cy="393192"/>
           </a:xfrm>
           <a:prstGeom prst="roundRect">
             <a:avLst>
@@ -14579,36 +14664,36 @@
       </p:sp>
       <p:sp>
         <p:nvSpPr>
-          <p:cNvPr id="6" name="TEXT: 同一输入：无风险标记 / 收款场景 / 审批候选条件"/>
-          <p:cNvSpPr txBox="1"/>
-          <p:nvPr/>
-        </p:nvSpPr>
-        <p:spPr>
-          <a:xfrm>
-            <a:off x="640080" y="2034540"/>
-            <a:ext cx="10899648" cy="228600"/>
-          </a:xfrm>
-          <a:prstGeom prst="rect">
-            <a:avLst/>
-          </a:prstGeom>
-          <a:noFill/>
-        </p:spPr>
-        <p:txBody>
-          <a:bodyPr wrap="square" lIns="13716" rIns="13716" tIns="0" bIns="0">
-            <a:spAutoFit/>
-          </a:bodyPr>
-          <a:lstStyle/>
-          <a:p>
-            <a:pPr algn="ctr">
-              <a:lnSpc>
-                <a:spcPct val="112000"/>
-              </a:lnSpc>
-              <a:spcAft>
-                <a:spcPts val="500"/>
-              </a:spcAft>
-            </a:pPr>
-            <a:r>
-              <a:rPr sz="1100" b="1">
+          <p:cNvPr id="9" name="TEXT: 候选条件：普通收款无风险 → 检查通过；退款才检查地址与人工审批。"/>
+          <p:cNvSpPr txBox="1"/>
+          <p:nvPr/>
+        </p:nvSpPr>
+        <p:spPr>
+          <a:xfrm>
+            <a:off x="768096" y="2670048"/>
+            <a:ext cx="10625328" cy="256032"/>
+          </a:xfrm>
+          <a:prstGeom prst="rect">
+            <a:avLst/>
+          </a:prstGeom>
+          <a:noFill/>
+        </p:spPr>
+        <p:txBody>
+          <a:bodyPr wrap="square" lIns="13716" rIns="13716" tIns="0" bIns="0">
+            <a:spAutoFit/>
+          </a:bodyPr>
+          <a:lstStyle/>
+          <a:p>
+            <a:pPr>
+              <a:lnSpc>
+                <a:spcPct val="112000"/>
+              </a:lnSpc>
+              <a:spcAft>
+                <a:spcPts val="500"/>
+              </a:spcAft>
+            </a:pPr>
+            <a:r>
+              <a:rPr sz="1500" b="1">
                 <a:solidFill>
                   <a:srgbClr val="087F72"/>
                 </a:solidFill>
@@ -14616,21 +14701,21 @@
                 <a:ea typeface="Noto Sans CJK SC"/>
                 <a:cs typeface="Noto Sans CJK SC"/>
               </a:rPr>
-              <a:t>同一输入：无风险标记 / 收款场景 / 审批候选条件</a:t>
-            </a:r>
-          </a:p>
-        </p:txBody>
-      </p:sp>
-      <p:sp>
-        <p:nvSpPr>
-          <p:cNvPr id="7" name="Rounded Rectangle 6"/>
+              <a:t>候选条件：普通收款无风险 → 检查通过；退款才检查地址与人工审批。</a:t>
+            </a:r>
+          </a:p>
+        </p:txBody>
+      </p:sp>
+      <p:sp>
+        <p:nvSpPr>
+          <p:cNvPr id="10" name="Rounded Rectangle 9"/>
           <p:cNvSpPr/>
           <p:nvPr/>
         </p:nvSpPr>
         <p:spPr>
           <a:xfrm>
-            <a:off x="594360" y="2642616"/>
-            <a:ext cx="5340096" cy="2907792"/>
+            <a:off x="594360" y="3154680"/>
+            <a:ext cx="5340096" cy="1920240"/>
           </a:xfrm>
           <a:prstGeom prst="roundRect">
             <a:avLst>
@@ -14671,22 +14756,22 @@
       </p:sp>
       <p:pic>
         <p:nvPicPr>
-          <p:cNvPr id="8" name="ICON: Lucide list-filter" descr="image.png"/>
+          <p:cNvPr id="11" name="ICON: Lucide list-filter" descr="image.png"/>
           <p:cNvPicPr>
             <a:picLocks noChangeAspect="1"/>
           </p:cNvPicPr>
           <p:nvPr/>
         </p:nvPicPr>
         <p:blipFill>
-          <a:blip r:embed="rId2"/>
+          <a:blip r:embed="rId3"/>
           <a:stretch>
             <a:fillRect/>
           </a:stretch>
         </p:blipFill>
         <p:spPr>
           <a:xfrm>
-            <a:off x="795528" y="2843784"/>
-            <a:ext cx="393192" cy="393192"/>
+            <a:off x="777240" y="3328416"/>
+            <a:ext cx="310896" cy="310896"/>
           </a:xfrm>
           <a:prstGeom prst="rect">
             <a:avLst/>
@@ -14695,36 +14780,36 @@
       </p:pic>
       <p:sp>
         <p:nvSpPr>
-          <p:cNvPr id="9" name="TEXT: Decider · 87.4 ms"/>
-          <p:cNvSpPr txBox="1"/>
-          <p:nvPr/>
-        </p:nvSpPr>
-        <p:spPr>
-          <a:xfrm>
-            <a:off x="1344168" y="2852928"/>
-            <a:ext cx="4407408" cy="365760"/>
-          </a:xfrm>
-          <a:prstGeom prst="rect">
-            <a:avLst/>
-          </a:prstGeom>
-          <a:noFill/>
-        </p:spPr>
-        <p:txBody>
-          <a:bodyPr wrap="square" lIns="13716" rIns="13716" tIns="0" bIns="0">
-            <a:spAutoFit/>
-          </a:bodyPr>
-          <a:lstStyle/>
-          <a:p>
-            <a:pPr>
-              <a:lnSpc>
-                <a:spcPct val="112000"/>
-              </a:lnSpc>
-              <a:spcAft>
-                <a:spcPts val="500"/>
-              </a:spcAft>
-            </a:pPr>
-            <a:r>
-              <a:rPr sz="1900" b="1">
+          <p:cNvPr id="12" name="TEXT: Decider · 87.4 ms"/>
+          <p:cNvSpPr txBox="1"/>
+          <p:nvPr/>
+        </p:nvSpPr>
+        <p:spPr>
+          <a:xfrm>
+            <a:off x="1234440" y="3291840"/>
+            <a:ext cx="4489704" cy="384048"/>
+          </a:xfrm>
+          <a:prstGeom prst="rect">
+            <a:avLst/>
+          </a:prstGeom>
+          <a:noFill/>
+        </p:spPr>
+        <p:txBody>
+          <a:bodyPr wrap="square" lIns="13716" rIns="13716" tIns="0" bIns="0">
+            <a:spAutoFit/>
+          </a:bodyPr>
+          <a:lstStyle/>
+          <a:p>
+            <a:pPr>
+              <a:lnSpc>
+                <a:spcPct val="112000"/>
+              </a:lnSpc>
+              <a:spcAft>
+                <a:spcPts val="500"/>
+              </a:spcAft>
+            </a:pPr>
+            <a:r>
+              <a:rPr sz="2100" b="1">
                 <a:solidFill>
                   <a:srgbClr val="087F72"/>
                 </a:solidFill>
@@ -14739,542 +14824,14 @@
       </p:sp>
       <p:sp>
         <p:nvSpPr>
-          <p:cNvPr id="10" name="TEXT: 等待人工审批"/>
-          <p:cNvSpPr txBox="1"/>
-          <p:nvPr/>
-        </p:nvSpPr>
-        <p:spPr>
-          <a:xfrm>
-            <a:off x="850392" y="3429000"/>
-            <a:ext cx="1901952" cy="274320"/>
-          </a:xfrm>
-          <a:prstGeom prst="rect">
-            <a:avLst/>
-          </a:prstGeom>
-          <a:noFill/>
-        </p:spPr>
-        <p:txBody>
-          <a:bodyPr wrap="square" lIns="13716" rIns="13716" tIns="0" bIns="0">
-            <a:spAutoFit/>
-          </a:bodyPr>
-          <a:lstStyle/>
-          <a:p>
-            <a:pPr>
-              <a:lnSpc>
-                <a:spcPct val="112000"/>
-              </a:lnSpc>
-              <a:spcAft>
-                <a:spcPts val="500"/>
-              </a:spcAft>
-            </a:pPr>
-            <a:r>
-              <a:rPr sz="1400" b="1">
-                <a:solidFill>
-                  <a:srgbClr val="203448"/>
-                </a:solidFill>
-                <a:latin typeface="Noto Sans CJK SC"/>
-                <a:ea typeface="Noto Sans CJK SC"/>
-                <a:cs typeface="Noto Sans CJK SC"/>
-              </a:rPr>
-              <a:t>等待人工审批</a:t>
-            </a:r>
-          </a:p>
-        </p:txBody>
-      </p:sp>
-      <p:sp>
-        <p:nvSpPr>
-          <p:cNvPr id="11" name="Rectangle 10"/>
+          <p:cNvPr id="13" name="Rounded Rectangle 12"/>
           <p:cNvSpPr/>
           <p:nvPr/>
         </p:nvSpPr>
         <p:spPr>
           <a:xfrm>
-            <a:off x="2807208" y="3502152"/>
-            <a:ext cx="1113402" cy="128016"/>
-          </a:xfrm>
-          <a:prstGeom prst="rect">
-            <a:avLst/>
-          </a:prstGeom>
-          <a:solidFill>
-            <a:srgbClr val="087F72"/>
-          </a:solidFill>
-          <a:ln>
-            <a:noFill/>
-          </a:ln>
-          <a:effectLst/>
-        </p:spPr>
-        <p:style>
-          <a:lnRef idx="1">
-            <a:schemeClr val="accent1"/>
-          </a:lnRef>
-          <a:fillRef idx="3">
-            <a:schemeClr val="accent1"/>
-          </a:fillRef>
-          <a:effectRef idx="0">
-            <a:schemeClr val="accent1"/>
-          </a:effectRef>
-          <a:fontRef idx="minor">
-            <a:schemeClr val="lt1"/>
-          </a:fontRef>
-        </p:style>
-        <p:txBody>
-          <a:bodyPr rtlCol="0" anchor="ctr"/>
-          <a:lstStyle/>
-          <a:p>
-            <a:pPr algn="ctr"/>
-          </a:p>
-        </p:txBody>
-      </p:sp>
-      <p:sp>
-        <p:nvSpPr>
-          <p:cNvPr id="12" name="TEXT: 58.5%"/>
-          <p:cNvSpPr txBox="1"/>
-          <p:nvPr/>
-        </p:nvSpPr>
-        <p:spPr>
-          <a:xfrm>
-            <a:off x="4800600" y="3429000"/>
-            <a:ext cx="850392" cy="274320"/>
-          </a:xfrm>
-          <a:prstGeom prst="rect">
-            <a:avLst/>
-          </a:prstGeom>
-          <a:noFill/>
-        </p:spPr>
-        <p:txBody>
-          <a:bodyPr wrap="square" lIns="13716" rIns="13716" tIns="0" bIns="0">
-            <a:spAutoFit/>
-          </a:bodyPr>
-          <a:lstStyle/>
-          <a:p>
-            <a:pPr>
-              <a:lnSpc>
-                <a:spcPct val="112000"/>
-              </a:lnSpc>
-              <a:spcAft>
-                <a:spcPts val="500"/>
-              </a:spcAft>
-            </a:pPr>
-            <a:r>
-              <a:rPr sz="1300" b="1">
-                <a:solidFill>
-                  <a:srgbClr val="087F72"/>
-                </a:solidFill>
-                <a:latin typeface="Noto Sans CJK SC"/>
-                <a:ea typeface="Noto Sans CJK SC"/>
-                <a:cs typeface="Noto Sans CJK SC"/>
-              </a:rPr>
-              <a:t>58.5%</a:t>
-            </a:r>
-          </a:p>
-        </p:txBody>
-      </p:sp>
-      <p:sp>
-        <p:nvSpPr>
-          <p:cNvPr id="13" name="TEXT: 规则检查通过"/>
-          <p:cNvSpPr txBox="1"/>
-          <p:nvPr/>
-        </p:nvSpPr>
-        <p:spPr>
-          <a:xfrm>
-            <a:off x="850392" y="3867912"/>
-            <a:ext cx="1901952" cy="274320"/>
-          </a:xfrm>
-          <a:prstGeom prst="rect">
-            <a:avLst/>
-          </a:prstGeom>
-          <a:noFill/>
-        </p:spPr>
-        <p:txBody>
-          <a:bodyPr wrap="square" lIns="13716" rIns="13716" tIns="0" bIns="0">
-            <a:spAutoFit/>
-          </a:bodyPr>
-          <a:lstStyle/>
-          <a:p>
-            <a:pPr>
-              <a:lnSpc>
-                <a:spcPct val="112000"/>
-              </a:lnSpc>
-              <a:spcAft>
-                <a:spcPts val="500"/>
-              </a:spcAft>
-            </a:pPr>
-            <a:r>
-              <a:rPr sz="1400" b="0">
-                <a:solidFill>
-                  <a:srgbClr val="203448"/>
-                </a:solidFill>
-                <a:latin typeface="Noto Sans CJK SC"/>
-                <a:ea typeface="Noto Sans CJK SC"/>
-                <a:cs typeface="Noto Sans CJK SC"/>
-              </a:rPr>
-              <a:t>规则检查通过</a:t>
-            </a:r>
-          </a:p>
-        </p:txBody>
-      </p:sp>
-      <p:sp>
-        <p:nvSpPr>
-          <p:cNvPr id="14" name="Rectangle 13"/>
-          <p:cNvSpPr/>
-          <p:nvPr/>
-        </p:nvSpPr>
-        <p:spPr>
-          <a:xfrm>
-            <a:off x="2807208" y="3941064"/>
-            <a:ext cx="351670" cy="128016"/>
-          </a:xfrm>
-          <a:prstGeom prst="rect">
-            <a:avLst/>
-          </a:prstGeom>
-          <a:solidFill>
-            <a:srgbClr val="087F72"/>
-          </a:solidFill>
-          <a:ln>
-            <a:noFill/>
-          </a:ln>
-          <a:effectLst/>
-        </p:spPr>
-        <p:style>
-          <a:lnRef idx="1">
-            <a:schemeClr val="accent1"/>
-          </a:lnRef>
-          <a:fillRef idx="3">
-            <a:schemeClr val="accent1"/>
-          </a:fillRef>
-          <a:effectRef idx="0">
-            <a:schemeClr val="accent1"/>
-          </a:effectRef>
-          <a:fontRef idx="minor">
-            <a:schemeClr val="lt1"/>
-          </a:fontRef>
-        </p:style>
-        <p:txBody>
-          <a:bodyPr rtlCol="0" anchor="ctr"/>
-          <a:lstStyle/>
-          <a:p>
-            <a:pPr algn="ctr"/>
-          </a:p>
-        </p:txBody>
-      </p:sp>
-      <p:sp>
-        <p:nvSpPr>
-          <p:cNvPr id="15" name="TEXT: 18.5%"/>
-          <p:cNvSpPr txBox="1"/>
-          <p:nvPr/>
-        </p:nvSpPr>
-        <p:spPr>
-          <a:xfrm>
-            <a:off x="4800600" y="3867912"/>
-            <a:ext cx="850392" cy="274320"/>
-          </a:xfrm>
-          <a:prstGeom prst="rect">
-            <a:avLst/>
-          </a:prstGeom>
-          <a:noFill/>
-        </p:spPr>
-        <p:txBody>
-          <a:bodyPr wrap="square" lIns="13716" rIns="13716" tIns="0" bIns="0">
-            <a:spAutoFit/>
-          </a:bodyPr>
-          <a:lstStyle/>
-          <a:p>
-            <a:pPr>
-              <a:lnSpc>
-                <a:spcPct val="112000"/>
-              </a:lnSpc>
-              <a:spcAft>
-                <a:spcPts val="500"/>
-              </a:spcAft>
-            </a:pPr>
-            <a:r>
-              <a:rPr sz="1300" b="1">
-                <a:solidFill>
-                  <a:srgbClr val="087F72"/>
-                </a:solidFill>
-                <a:latin typeface="Noto Sans CJK SC"/>
-                <a:ea typeface="Noto Sans CJK SC"/>
-                <a:cs typeface="Noto Sans CJK SC"/>
-              </a:rPr>
-              <a:t>18.5%</a:t>
-            </a:r>
-          </a:p>
-        </p:txBody>
-      </p:sp>
-      <p:sp>
-        <p:nvSpPr>
-          <p:cNvPr id="16" name="TEXT: 风险复核"/>
-          <p:cNvSpPr txBox="1"/>
-          <p:nvPr/>
-        </p:nvSpPr>
-        <p:spPr>
-          <a:xfrm>
-            <a:off x="850392" y="4306824"/>
-            <a:ext cx="1901952" cy="274320"/>
-          </a:xfrm>
-          <a:prstGeom prst="rect">
-            <a:avLst/>
-          </a:prstGeom>
-          <a:noFill/>
-        </p:spPr>
-        <p:txBody>
-          <a:bodyPr wrap="square" lIns="13716" rIns="13716" tIns="0" bIns="0">
-            <a:spAutoFit/>
-          </a:bodyPr>
-          <a:lstStyle/>
-          <a:p>
-            <a:pPr>
-              <a:lnSpc>
-                <a:spcPct val="112000"/>
-              </a:lnSpc>
-              <a:spcAft>
-                <a:spcPts val="500"/>
-              </a:spcAft>
-            </a:pPr>
-            <a:r>
-              <a:rPr sz="1400" b="0">
-                <a:solidFill>
-                  <a:srgbClr val="203448"/>
-                </a:solidFill>
-                <a:latin typeface="Noto Sans CJK SC"/>
-                <a:ea typeface="Noto Sans CJK SC"/>
-                <a:cs typeface="Noto Sans CJK SC"/>
-              </a:rPr>
-              <a:t>风险复核</a:t>
-            </a:r>
-          </a:p>
-        </p:txBody>
-      </p:sp>
-      <p:sp>
-        <p:nvSpPr>
-          <p:cNvPr id="17" name="Rectangle 16"/>
-          <p:cNvSpPr/>
-          <p:nvPr/>
-        </p:nvSpPr>
-        <p:spPr>
-          <a:xfrm>
-            <a:off x="2807208" y="4379976"/>
-            <a:ext cx="308116" cy="128016"/>
-          </a:xfrm>
-          <a:prstGeom prst="rect">
-            <a:avLst/>
-          </a:prstGeom>
-          <a:solidFill>
-            <a:srgbClr val="087F72"/>
-          </a:solidFill>
-          <a:ln>
-            <a:noFill/>
-          </a:ln>
-          <a:effectLst/>
-        </p:spPr>
-        <p:style>
-          <a:lnRef idx="1">
-            <a:schemeClr val="accent1"/>
-          </a:lnRef>
-          <a:fillRef idx="3">
-            <a:schemeClr val="accent1"/>
-          </a:fillRef>
-          <a:effectRef idx="0">
-            <a:schemeClr val="accent1"/>
-          </a:effectRef>
-          <a:fontRef idx="minor">
-            <a:schemeClr val="lt1"/>
-          </a:fontRef>
-        </p:style>
-        <p:txBody>
-          <a:bodyPr rtlCol="0" anchor="ctr"/>
-          <a:lstStyle/>
-          <a:p>
-            <a:pPr algn="ctr"/>
-          </a:p>
-        </p:txBody>
-      </p:sp>
-      <p:sp>
-        <p:nvSpPr>
-          <p:cNvPr id="18" name="TEXT: 16.2%"/>
-          <p:cNvSpPr txBox="1"/>
-          <p:nvPr/>
-        </p:nvSpPr>
-        <p:spPr>
-          <a:xfrm>
-            <a:off x="4800600" y="4306824"/>
-            <a:ext cx="850392" cy="274320"/>
-          </a:xfrm>
-          <a:prstGeom prst="rect">
-            <a:avLst/>
-          </a:prstGeom>
-          <a:noFill/>
-        </p:spPr>
-        <p:txBody>
-          <a:bodyPr wrap="square" lIns="13716" rIns="13716" tIns="0" bIns="0">
-            <a:spAutoFit/>
-          </a:bodyPr>
-          <a:lstStyle/>
-          <a:p>
-            <a:pPr>
-              <a:lnSpc>
-                <a:spcPct val="112000"/>
-              </a:lnSpc>
-              <a:spcAft>
-                <a:spcPts val="500"/>
-              </a:spcAft>
-            </a:pPr>
-            <a:r>
-              <a:rPr sz="1300" b="1">
-                <a:solidFill>
-                  <a:srgbClr val="087F72"/>
-                </a:solidFill>
-                <a:latin typeface="Noto Sans CJK SC"/>
-                <a:ea typeface="Noto Sans CJK SC"/>
-                <a:cs typeface="Noto Sans CJK SC"/>
-              </a:rPr>
-              <a:t>16.2%</a:t>
-            </a:r>
-          </a:p>
-        </p:txBody>
-      </p:sp>
-      <p:sp>
-        <p:nvSpPr>
-          <p:cNvPr id="19" name="TEXT: 验证退款地址"/>
-          <p:cNvSpPr txBox="1"/>
-          <p:nvPr/>
-        </p:nvSpPr>
-        <p:spPr>
-          <a:xfrm>
-            <a:off x="850392" y="4745736"/>
-            <a:ext cx="1901952" cy="274320"/>
-          </a:xfrm>
-          <a:prstGeom prst="rect">
-            <a:avLst/>
-          </a:prstGeom>
-          <a:noFill/>
-        </p:spPr>
-        <p:txBody>
-          <a:bodyPr wrap="square" lIns="13716" rIns="13716" tIns="0" bIns="0">
-            <a:spAutoFit/>
-          </a:bodyPr>
-          <a:lstStyle/>
-          <a:p>
-            <a:pPr>
-              <a:lnSpc>
-                <a:spcPct val="112000"/>
-              </a:lnSpc>
-              <a:spcAft>
-                <a:spcPts val="500"/>
-              </a:spcAft>
-            </a:pPr>
-            <a:r>
-              <a:rPr sz="1400" b="0">
-                <a:solidFill>
-                  <a:srgbClr val="203448"/>
-                </a:solidFill>
-                <a:latin typeface="Noto Sans CJK SC"/>
-                <a:ea typeface="Noto Sans CJK SC"/>
-                <a:cs typeface="Noto Sans CJK SC"/>
-              </a:rPr>
-              <a:t>验证退款地址</a:t>
-            </a:r>
-          </a:p>
-        </p:txBody>
-      </p:sp>
-      <p:sp>
-        <p:nvSpPr>
-          <p:cNvPr id="20" name="Rectangle 19"/>
-          <p:cNvSpPr/>
-          <p:nvPr/>
-        </p:nvSpPr>
-        <p:spPr>
-          <a:xfrm>
-            <a:off x="2807208" y="4818888"/>
-            <a:ext cx="128952" cy="128016"/>
-          </a:xfrm>
-          <a:prstGeom prst="rect">
-            <a:avLst/>
-          </a:prstGeom>
-          <a:solidFill>
-            <a:srgbClr val="087F72"/>
-          </a:solidFill>
-          <a:ln>
-            <a:noFill/>
-          </a:ln>
-          <a:effectLst/>
-        </p:spPr>
-        <p:style>
-          <a:lnRef idx="1">
-            <a:schemeClr val="accent1"/>
-          </a:lnRef>
-          <a:fillRef idx="3">
-            <a:schemeClr val="accent1"/>
-          </a:fillRef>
-          <a:effectRef idx="0">
-            <a:schemeClr val="accent1"/>
-          </a:effectRef>
-          <a:fontRef idx="minor">
-            <a:schemeClr val="lt1"/>
-          </a:fontRef>
-        </p:style>
-        <p:txBody>
-          <a:bodyPr rtlCol="0" anchor="ctr"/>
-          <a:lstStyle/>
-          <a:p>
-            <a:pPr algn="ctr"/>
-          </a:p>
-        </p:txBody>
-      </p:sp>
-      <p:sp>
-        <p:nvSpPr>
-          <p:cNvPr id="21" name="TEXT: 6.8%"/>
-          <p:cNvSpPr txBox="1"/>
-          <p:nvPr/>
-        </p:nvSpPr>
-        <p:spPr>
-          <a:xfrm>
-            <a:off x="4800600" y="4745736"/>
-            <a:ext cx="850392" cy="274320"/>
-          </a:xfrm>
-          <a:prstGeom prst="rect">
-            <a:avLst/>
-          </a:prstGeom>
-          <a:noFill/>
-        </p:spPr>
-        <p:txBody>
-          <a:bodyPr wrap="square" lIns="13716" rIns="13716" tIns="0" bIns="0">
-            <a:spAutoFit/>
-          </a:bodyPr>
-          <a:lstStyle/>
-          <a:p>
-            <a:pPr>
-              <a:lnSpc>
-                <a:spcPct val="112000"/>
-              </a:lnSpc>
-              <a:spcAft>
-                <a:spcPts val="500"/>
-              </a:spcAft>
-            </a:pPr>
-            <a:r>
-              <a:rPr sz="1300" b="1">
-                <a:solidFill>
-                  <a:srgbClr val="087F72"/>
-                </a:solidFill>
-                <a:latin typeface="Noto Sans CJK SC"/>
-                <a:ea typeface="Noto Sans CJK SC"/>
-                <a:cs typeface="Noto Sans CJK SC"/>
-              </a:rPr>
-              <a:t>6.8%</a:t>
-            </a:r>
-          </a:p>
-        </p:txBody>
-      </p:sp>
-      <p:sp>
-        <p:nvSpPr>
-          <p:cNvPr id="22" name="Rounded Rectangle 21"/>
-          <p:cNvSpPr/>
-          <p:nvPr/>
-        </p:nvSpPr>
-        <p:spPr>
-          <a:xfrm>
-            <a:off x="6208776" y="2642616"/>
-            <a:ext cx="5340096" cy="2907792"/>
+            <a:off x="6208776" y="3154680"/>
+            <a:ext cx="5340096" cy="1920240"/>
           </a:xfrm>
           <a:prstGeom prst="roundRect">
             <a:avLst>
@@ -15315,22 +14872,22 @@
       </p:sp>
       <p:pic>
         <p:nvPicPr>
-          <p:cNvPr id="23" name="ICON: Lucide code-xml" descr="image.png"/>
+          <p:cNvPr id="14" name="ICON: Lucide code-xml" descr="image.png"/>
           <p:cNvPicPr>
             <a:picLocks noChangeAspect="1"/>
           </p:cNvPicPr>
           <p:nvPr/>
         </p:nvPicPr>
         <p:blipFill>
-          <a:blip r:embed="rId3"/>
+          <a:blip r:embed="rId2"/>
           <a:stretch>
             <a:fillRect/>
           </a:stretch>
         </p:blipFill>
         <p:spPr>
           <a:xfrm>
-            <a:off x="6409944" y="2843784"/>
-            <a:ext cx="393192" cy="393192"/>
+            <a:off x="6391656" y="3328416"/>
+            <a:ext cx="310896" cy="310896"/>
           </a:xfrm>
           <a:prstGeom prst="rect">
             <a:avLst/>
@@ -15339,14 +14896,102 @@
       </p:pic>
       <p:sp>
         <p:nvSpPr>
-          <p:cNvPr id="24" name="TEXT: GPT · 3,771.8 ms"/>
-          <p:cNvSpPr txBox="1"/>
-          <p:nvPr/>
-        </p:nvSpPr>
-        <p:spPr>
-          <a:xfrm>
-            <a:off x="6958584" y="2852928"/>
-            <a:ext cx="4407408" cy="365760"/>
+          <p:cNvPr id="15" name="TEXT: GPT · 3,771.8 ms"/>
+          <p:cNvSpPr txBox="1"/>
+          <p:nvPr/>
+        </p:nvSpPr>
+        <p:spPr>
+          <a:xfrm>
+            <a:off x="6848856" y="3291840"/>
+            <a:ext cx="4489704" cy="384048"/>
+          </a:xfrm>
+          <a:prstGeom prst="rect">
+            <a:avLst/>
+          </a:prstGeom>
+          <a:noFill/>
+        </p:spPr>
+        <p:txBody>
+          <a:bodyPr wrap="square" lIns="13716" rIns="13716" tIns="0" bIns="0">
+            <a:spAutoFit/>
+          </a:bodyPr>
+          <a:lstStyle/>
+          <a:p>
+            <a:pPr>
+              <a:lnSpc>
+                <a:spcPct val="112000"/>
+              </a:lnSpc>
+              <a:spcAft>
+                <a:spcPts val="500"/>
+              </a:spcAft>
+            </a:pPr>
+            <a:r>
+              <a:rPr sz="2100" b="1">
+                <a:solidFill>
+                  <a:srgbClr val="4669C4"/>
+                </a:solidFill>
+                <a:latin typeface="Noto Sans CJK SC"/>
+                <a:ea typeface="Noto Sans CJK SC"/>
+                <a:cs typeface="Noto Sans CJK SC"/>
+              </a:rPr>
+              <a:t>GPT · 3,771.8 ms</a:t>
+            </a:r>
+          </a:p>
+        </p:txBody>
+      </p:sp>
+      <p:sp>
+        <p:nvSpPr>
+          <p:cNvPr id="16" name="TEXT: 候选评分 → 取最高分"/>
+          <p:cNvSpPr txBox="1"/>
+          <p:nvPr/>
+        </p:nvSpPr>
+        <p:spPr>
+          <a:xfrm>
+            <a:off x="822960" y="3749039"/>
+            <a:ext cx="4846320" cy="274320"/>
+          </a:xfrm>
+          <a:prstGeom prst="rect">
+            <a:avLst/>
+          </a:prstGeom>
+          <a:noFill/>
+        </p:spPr>
+        <p:txBody>
+          <a:bodyPr wrap="square" lIns="13716" rIns="13716" tIns="0" bIns="0">
+            <a:spAutoFit/>
+          </a:bodyPr>
+          <a:lstStyle/>
+          <a:p>
+            <a:pPr>
+              <a:lnSpc>
+                <a:spcPct val="112000"/>
+              </a:lnSpc>
+              <a:spcAft>
+                <a:spcPts val="500"/>
+              </a:spcAft>
+            </a:pPr>
+            <a:r>
+              <a:rPr sz="1600" b="0">
+                <a:solidFill>
+                  <a:srgbClr val="203448"/>
+                </a:solidFill>
+                <a:latin typeface="Noto Sans CJK SC"/>
+                <a:ea typeface="Noto Sans CJK SC"/>
+                <a:cs typeface="Noto Sans CJK SC"/>
+              </a:rPr>
+              <a:t>候选评分 → 取最高分</a:t>
+            </a:r>
+          </a:p>
+        </p:txBody>
+      </p:sp>
+      <p:sp>
+        <p:nvSpPr>
+          <p:cNvPr id="17" name="TEXT: 选择「等待人工审批」"/>
+          <p:cNvSpPr txBox="1"/>
+          <p:nvPr/>
+        </p:nvSpPr>
+        <p:spPr>
+          <a:xfrm>
+            <a:off x="822960" y="4114800"/>
+            <a:ext cx="4846320" cy="310896"/>
           </a:xfrm>
           <a:prstGeom prst="rect">
             <a:avLst/>
@@ -15370,49 +15015,313 @@
             <a:r>
               <a:rPr sz="1900" b="1">
                 <a:solidFill>
+                  <a:srgbClr val="087F72"/>
+                </a:solidFill>
+                <a:latin typeface="Noto Sans CJK SC"/>
+                <a:ea typeface="Noto Sans CJK SC"/>
+                <a:cs typeface="Noto Sans CJK SC"/>
+              </a:rPr>
+              <a:t>选择「等待人工审批」</a:t>
+            </a:r>
+          </a:p>
+        </p:txBody>
+      </p:sp>
+      <p:sp>
+        <p:nvSpPr>
+          <p:cNvPr id="18" name="TEXT: 等待审批 58.54%  &gt;  检查通过 18.49%"/>
+          <p:cNvSpPr txBox="1"/>
+          <p:nvPr/>
+        </p:nvSpPr>
+        <p:spPr>
+          <a:xfrm>
+            <a:off x="822960" y="4517136"/>
+            <a:ext cx="4846320" cy="256032"/>
+          </a:xfrm>
+          <a:prstGeom prst="rect">
+            <a:avLst/>
+          </a:prstGeom>
+          <a:noFill/>
+        </p:spPr>
+        <p:txBody>
+          <a:bodyPr wrap="square" lIns="13716" rIns="13716" tIns="0" bIns="0">
+            <a:spAutoFit/>
+          </a:bodyPr>
+          <a:lstStyle/>
+          <a:p>
+            <a:pPr>
+              <a:lnSpc>
+                <a:spcPct val="112000"/>
+              </a:lnSpc>
+              <a:spcAft>
+                <a:spcPts val="500"/>
+              </a:spcAft>
+            </a:pPr>
+            <a:r>
+              <a:rPr sz="1300" b="0">
+                <a:solidFill>
+                  <a:srgbClr val="64788A"/>
+                </a:solidFill>
+                <a:latin typeface="Noto Sans CJK SC"/>
+                <a:ea typeface="Noto Sans CJK SC"/>
+                <a:cs typeface="Noto Sans CJK SC"/>
+              </a:rPr>
+              <a:t>等待审批 58.54%  &gt;  检查通过 18.49%</a:t>
+            </a:r>
+          </a:p>
+        </p:txBody>
+      </p:sp>
+      <p:sp>
+        <p:nvSpPr>
+          <p:cNvPr id="19" name="TEXT: 本例增加了不需要的审批。"/>
+          <p:cNvSpPr txBox="1"/>
+          <p:nvPr/>
+        </p:nvSpPr>
+        <p:spPr>
+          <a:xfrm>
+            <a:off x="822960" y="4800600"/>
+            <a:ext cx="4846320" cy="246888"/>
+          </a:xfrm>
+          <a:prstGeom prst="rect">
+            <a:avLst/>
+          </a:prstGeom>
+          <a:noFill/>
+        </p:spPr>
+        <p:txBody>
+          <a:bodyPr wrap="square" lIns="13716" rIns="13716" tIns="0" bIns="0">
+            <a:spAutoFit/>
+          </a:bodyPr>
+          <a:lstStyle/>
+          <a:p>
+            <a:pPr>
+              <a:lnSpc>
+                <a:spcPct val="112000"/>
+              </a:lnSpc>
+              <a:spcAft>
+                <a:spcPts val="500"/>
+              </a:spcAft>
+            </a:pPr>
+            <a:r>
+              <a:rPr sz="1400" b="1">
+                <a:solidFill>
+                  <a:srgbClr val="BE721F"/>
+                </a:solidFill>
+                <a:latin typeface="Noto Sans CJK SC"/>
+                <a:ea typeface="Noto Sans CJK SC"/>
+                <a:cs typeface="Noto Sans CJK SC"/>
+              </a:rPr>
+              <a:t>本例增加了不需要的审批。</a:t>
+            </a:r>
+          </a:p>
+        </p:txBody>
+      </p:sp>
+      <p:sp>
+        <p:nvSpPr>
+          <p:cNvPr id="20" name="TEXT: 按候选条件生成 JSON"/>
+          <p:cNvSpPr txBox="1"/>
+          <p:nvPr/>
+        </p:nvSpPr>
+        <p:spPr>
+          <a:xfrm>
+            <a:off x="6437376" y="3749039"/>
+            <a:ext cx="4846320" cy="274320"/>
+          </a:xfrm>
+          <a:prstGeom prst="rect">
+            <a:avLst/>
+          </a:prstGeom>
+          <a:noFill/>
+        </p:spPr>
+        <p:txBody>
+          <a:bodyPr wrap="square" lIns="13716" rIns="13716" tIns="0" bIns="0">
+            <a:spAutoFit/>
+          </a:bodyPr>
+          <a:lstStyle/>
+          <a:p>
+            <a:pPr>
+              <a:lnSpc>
+                <a:spcPct val="112000"/>
+              </a:lnSpc>
+              <a:spcAft>
+                <a:spcPts val="500"/>
+              </a:spcAft>
+            </a:pPr>
+            <a:r>
+              <a:rPr sz="1600" b="0">
+                <a:solidFill>
+                  <a:srgbClr val="203448"/>
+                </a:solidFill>
+                <a:latin typeface="Noto Sans CJK SC"/>
+                <a:ea typeface="Noto Sans CJK SC"/>
+                <a:cs typeface="Noto Sans CJK SC"/>
+              </a:rPr>
+              <a:t>按候选条件生成 JSON</a:t>
+            </a:r>
+          </a:p>
+        </p:txBody>
+      </p:sp>
+      <p:sp>
+        <p:nvSpPr>
+          <p:cNvPr id="21" name="TEXT: {&quot;choice&quot;: &quot;approved&quot;}"/>
+          <p:cNvSpPr txBox="1"/>
+          <p:nvPr/>
+        </p:nvSpPr>
+        <p:spPr>
+          <a:xfrm>
+            <a:off x="6437376" y="4114800"/>
+            <a:ext cx="4846320" cy="310896"/>
+          </a:xfrm>
+          <a:prstGeom prst="rect">
+            <a:avLst/>
+          </a:prstGeom>
+          <a:noFill/>
+        </p:spPr>
+        <p:txBody>
+          <a:bodyPr wrap="square" lIns="13716" rIns="13716" tIns="0" bIns="0">
+            <a:spAutoFit/>
+          </a:bodyPr>
+          <a:lstStyle/>
+          <a:p>
+            <a:pPr>
+              <a:lnSpc>
+                <a:spcPct val="112000"/>
+              </a:lnSpc>
+              <a:spcAft>
+                <a:spcPts val="500"/>
+              </a:spcAft>
+            </a:pPr>
+            <a:r>
+              <a:rPr sz="1900" b="1">
+                <a:solidFill>
                   <a:srgbClr val="4669C4"/>
                 </a:solidFill>
                 <a:latin typeface="Noto Sans CJK SC"/>
                 <a:ea typeface="Noto Sans CJK SC"/>
                 <a:cs typeface="Noto Sans CJK SC"/>
               </a:rPr>
-              <a:t>GPT · 3,771.8 ms</a:t>
-            </a:r>
-          </a:p>
-        </p:txBody>
-      </p:sp>
-      <p:sp>
-        <p:nvSpPr>
-          <p:cNvPr id="25" name="TEXT: 输出候选 ID {&quot;choice&quot;: &quot;approved&quot;} → 规则检查通过"/>
-          <p:cNvSpPr txBox="1"/>
-          <p:nvPr/>
-        </p:nvSpPr>
-        <p:spPr>
-          <a:xfrm>
-            <a:off x="6419088" y="3493008"/>
-            <a:ext cx="4919472" cy="1975104"/>
-          </a:xfrm>
-          <a:prstGeom prst="rect">
-            <a:avLst/>
-          </a:prstGeom>
-          <a:noFill/>
-        </p:spPr>
-        <p:txBody>
-          <a:bodyPr wrap="square" lIns="13716" rIns="13716" tIns="0" bIns="0">
-            <a:spAutoFit/>
-          </a:bodyPr>
-          <a:lstStyle/>
-          <a:p>
-            <a:pPr>
-              <a:lnSpc>
-                <a:spcPct val="112000"/>
-              </a:lnSpc>
-              <a:spcAft>
-                <a:spcPts val="500"/>
-              </a:spcAft>
-            </a:pPr>
-            <a:r>
-              <a:rPr sz="1800" b="0">
+              <a:t>{"choice": "approved"}</a:t>
+            </a:r>
+          </a:p>
+        </p:txBody>
+      </p:sp>
+      <p:sp>
+        <p:nvSpPr>
+          <p:cNvPr id="22" name="TEXT: 界面标签：「规则检查通过」"/>
+          <p:cNvSpPr txBox="1"/>
+          <p:nvPr/>
+        </p:nvSpPr>
+        <p:spPr>
+          <a:xfrm>
+            <a:off x="6437376" y="4517136"/>
+            <a:ext cx="4846320" cy="256032"/>
+          </a:xfrm>
+          <a:prstGeom prst="rect">
+            <a:avLst/>
+          </a:prstGeom>
+          <a:noFill/>
+        </p:spPr>
+        <p:txBody>
+          <a:bodyPr wrap="square" lIns="13716" rIns="13716" tIns="0" bIns="0">
+            <a:spAutoFit/>
+          </a:bodyPr>
+          <a:lstStyle/>
+          <a:p>
+            <a:pPr>
+              <a:lnSpc>
+                <a:spcPct val="112000"/>
+              </a:lnSpc>
+              <a:spcAft>
+                <a:spcPts val="500"/>
+              </a:spcAft>
+            </a:pPr>
+            <a:r>
+              <a:rPr sz="1300" b="0">
+                <a:solidFill>
+                  <a:srgbClr val="64788A"/>
+                </a:solidFill>
+                <a:latin typeface="Noto Sans CJK SC"/>
+                <a:ea typeface="Noto Sans CJK SC"/>
+                <a:cs typeface="Noto Sans CJK SC"/>
+              </a:rPr>
+              <a:t>界面标签：「规则检查通过」</a:t>
+            </a:r>
+          </a:p>
+        </p:txBody>
+      </p:sp>
+      <p:sp>
+        <p:nvSpPr>
+          <p:cNvPr id="23" name="TEXT: 本次选择符合“非退款无需退款审批”。"/>
+          <p:cNvSpPr txBox="1"/>
+          <p:nvPr/>
+        </p:nvSpPr>
+        <p:spPr>
+          <a:xfrm>
+            <a:off x="6437376" y="4800600"/>
+            <a:ext cx="4846320" cy="246888"/>
+          </a:xfrm>
+          <a:prstGeom prst="rect">
+            <a:avLst/>
+          </a:prstGeom>
+          <a:noFill/>
+        </p:spPr>
+        <p:txBody>
+          <a:bodyPr wrap="square" lIns="13716" rIns="13716" tIns="0" bIns="0">
+            <a:spAutoFit/>
+          </a:bodyPr>
+          <a:lstStyle/>
+          <a:p>
+            <a:pPr>
+              <a:lnSpc>
+                <a:spcPct val="112000"/>
+              </a:lnSpc>
+              <a:spcAft>
+                <a:spcPts val="500"/>
+              </a:spcAft>
+            </a:pPr>
+            <a:r>
+              <a:rPr sz="1400" b="1">
+                <a:solidFill>
+                  <a:srgbClr val="4669C4"/>
+                </a:solidFill>
+                <a:latin typeface="Noto Sans CJK SC"/>
+                <a:ea typeface="Noto Sans CJK SC"/>
+                <a:cs typeface="Noto Sans CJK SC"/>
+              </a:rPr>
+              <a:t>本次选择符合“非退款无需退款审批”。</a:t>
+            </a:r>
+          </a:p>
+        </p:txBody>
+      </p:sp>
+      <p:sp>
+        <p:nvSpPr>
+          <p:cNvPr id="24" name="TEXT: 为何会不同？自然语言条件由模型判断，并非程序 if/else。"/>
+          <p:cNvSpPr txBox="1"/>
+          <p:nvPr/>
+        </p:nvSpPr>
+        <p:spPr>
+          <a:xfrm>
+            <a:off x="594360" y="5294376"/>
+            <a:ext cx="10972800" cy="301752"/>
+          </a:xfrm>
+          <a:prstGeom prst="rect">
+            <a:avLst/>
+          </a:prstGeom>
+          <a:noFill/>
+        </p:spPr>
+        <p:txBody>
+          <a:bodyPr wrap="square" lIns="13716" rIns="13716" tIns="0" bIns="0">
+            <a:spAutoFit/>
+          </a:bodyPr>
+          <a:lstStyle/>
+          <a:p>
+            <a:pPr>
+              <a:lnSpc>
+                <a:spcPct val="112000"/>
+              </a:lnSpc>
+              <a:spcAft>
+                <a:spcPts val="500"/>
+              </a:spcAft>
+            </a:pPr>
+            <a:r>
+              <a:rPr sz="1600" b="1">
                 <a:solidFill>
                   <a:srgbClr val="203448"/>
                 </a:solidFill>
@@ -15420,85 +15329,43 @@
                 <a:ea typeface="Noto Sans CJK SC"/>
                 <a:cs typeface="Noto Sans CJK SC"/>
               </a:rPr>
-              <a:t>输出候选 ID</a:t>
-            </a:r>
-          </a:p>
-          <a:p>
-            <a:pPr>
-              <a:lnSpc>
-                <a:spcPct val="112000"/>
-              </a:lnSpc>
-              <a:spcAft>
-                <a:spcPts val="500"/>
-              </a:spcAft>
-            </a:pPr>
-            <a:r>
-              <a:rPr sz="1800" b="0">
-                <a:solidFill>
-                  <a:srgbClr val="203448"/>
-                </a:solidFill>
-                <a:latin typeface="Noto Sans CJK SC"/>
-                <a:ea typeface="Noto Sans CJK SC"/>
-                <a:cs typeface="Noto Sans CJK SC"/>
-              </a:rPr>
-              <a:t>{"choice": "approved"}</a:t>
-            </a:r>
-          </a:p>
-          <a:p>
-            <a:pPr>
-              <a:lnSpc>
-                <a:spcPct val="112000"/>
-              </a:lnSpc>
-              <a:spcAft>
-                <a:spcPts val="500"/>
-              </a:spcAft>
-            </a:pPr>
-            <a:r>
-              <a:rPr sz="1800" b="0">
-                <a:solidFill>
-                  <a:srgbClr val="203448"/>
-                </a:solidFill>
-                <a:latin typeface="Noto Sans CJK SC"/>
-                <a:ea typeface="Noto Sans CJK SC"/>
-                <a:cs typeface="Noto Sans CJK SC"/>
-              </a:rPr>
-              <a:t>→ 规则检查通过</a:t>
-            </a:r>
-          </a:p>
-        </p:txBody>
-      </p:sp>
-      <p:sp>
-        <p:nvSpPr>
-          <p:cNvPr id="26" name="TEXT: 演示参考为「规则检查通过」；参考符合度不是通用准确率，概率也不是正确率。"/>
-          <p:cNvSpPr txBox="1"/>
-          <p:nvPr/>
-        </p:nvSpPr>
-        <p:spPr>
-          <a:xfrm>
-            <a:off x="566928" y="6080760"/>
-            <a:ext cx="11018520" cy="283464"/>
-          </a:xfrm>
-          <a:prstGeom prst="rect">
-            <a:avLst/>
-          </a:prstGeom>
-          <a:noFill/>
-        </p:spPr>
-        <p:txBody>
-          <a:bodyPr wrap="square" lIns="13716" rIns="13716" tIns="0" bIns="0">
-            <a:spAutoFit/>
-          </a:bodyPr>
-          <a:lstStyle/>
-          <a:p>
-            <a:pPr>
-              <a:lnSpc>
-                <a:spcPct val="112000"/>
-              </a:lnSpc>
-              <a:spcAft>
-                <a:spcPts val="500"/>
-              </a:spcAft>
-            </a:pPr>
-            <a:r>
-              <a:rPr sz="1150" b="0">
+              <a:t>为何会不同？自然语言条件由模型判断，并非程序 if/else。</a:t>
+            </a:r>
+          </a:p>
+        </p:txBody>
+      </p:sp>
+      <p:sp>
+        <p:nvSpPr>
+          <p:cNvPr id="25" name="TEXT: 可能干扰：退款审批字段在本例不适用；内部原因尚不能确认。候选概率表示偏向，不是正确率。"/>
+          <p:cNvSpPr txBox="1"/>
+          <p:nvPr/>
+        </p:nvSpPr>
+        <p:spPr>
+          <a:xfrm>
+            <a:off x="594360" y="5687568"/>
+            <a:ext cx="10972800" cy="310896"/>
+          </a:xfrm>
+          <a:prstGeom prst="rect">
+            <a:avLst/>
+          </a:prstGeom>
+          <a:noFill/>
+        </p:spPr>
+        <p:txBody>
+          <a:bodyPr wrap="square" lIns="13716" rIns="13716" tIns="0" bIns="0">
+            <a:spAutoFit/>
+          </a:bodyPr>
+          <a:lstStyle/>
+          <a:p>
+            <a:pPr>
+              <a:lnSpc>
+                <a:spcPct val="112000"/>
+              </a:lnSpc>
+              <a:spcAft>
+                <a:spcPts val="500"/>
+              </a:spcAft>
+            </a:pPr>
+            <a:r>
+              <a:rPr sz="1350" b="0">
                 <a:solidFill>
                   <a:srgbClr val="64788A"/>
                 </a:solidFill>
@@ -15506,7 +15373,51 @@
                 <a:ea typeface="Noto Sans CJK SC"/>
                 <a:cs typeface="Noto Sans CJK SC"/>
               </a:rPr>
-              <a:t>演示参考为「规则检查通过」；参考符合度不是通用准确率，概率也不是正确率。</a:t>
+              <a:t>可能干扰：退款审批字段在本例不适用；内部原因尚不能确认。候选概率表示偏向，不是正确率。</a:t>
+            </a:r>
+          </a:p>
+        </p:txBody>
+      </p:sp>
+      <p:sp>
+        <p:nvSpPr>
+          <p:cNvPr id="26" name="TEXT: 业务结果：检查通过 ≠ 已到账；两侧仍等待确认达标，Decider 另有待审批状态。"/>
+          <p:cNvSpPr txBox="1"/>
+          <p:nvPr/>
+        </p:nvSpPr>
+        <p:spPr>
+          <a:xfrm>
+            <a:off x="594360" y="6080760"/>
+            <a:ext cx="10972800" cy="283464"/>
+          </a:xfrm>
+          <a:prstGeom prst="rect">
+            <a:avLst/>
+          </a:prstGeom>
+          <a:noFill/>
+        </p:spPr>
+        <p:txBody>
+          <a:bodyPr wrap="square" lIns="13716" rIns="13716" tIns="0" bIns="0">
+            <a:spAutoFit/>
+          </a:bodyPr>
+          <a:lstStyle/>
+          <a:p>
+            <a:pPr>
+              <a:lnSpc>
+                <a:spcPct val="112000"/>
+              </a:lnSpc>
+              <a:spcAft>
+                <a:spcPts val="500"/>
+              </a:spcAft>
+            </a:pPr>
+            <a:r>
+              <a:rPr sz="1400" b="1">
+                <a:solidFill>
+                  <a:srgbClr val="087F72"/>
+                </a:solidFill>
+                <a:latin typeface="Noto Sans CJK SC"/>
+                <a:ea typeface="Noto Sans CJK SC"/>
+                <a:cs typeface="Noto Sans CJK SC"/>
+              </a:rPr>
+              <a:t>业务结果：检查通过 ≠ 已到账；两侧仍等待确认达标，Decider 另有待审批状态。</a:t>
             </a:r>
           </a:p>
         </p:txBody>
@@ -15548,51 +15459,7 @@
       </p:cxnSp>
       <p:sp>
         <p:nvSpPr>
-          <p:cNvPr id="28" name="TEXT: 历史实测：2026-10-10 · 迁移前的托管部署；当前 EC2 架构见第 9 页"/>
-          <p:cNvSpPr txBox="1"/>
-          <p:nvPr/>
-        </p:nvSpPr>
-        <p:spPr>
-          <a:xfrm>
-            <a:off x="585216" y="6547104"/>
-            <a:ext cx="9052560" cy="192024"/>
-          </a:xfrm>
-          <a:prstGeom prst="rect">
-            <a:avLst/>
-          </a:prstGeom>
-          <a:noFill/>
-        </p:spPr>
-        <p:txBody>
-          <a:bodyPr wrap="square" lIns="13716" rIns="13716" tIns="0" bIns="0">
-            <a:spAutoFit/>
-          </a:bodyPr>
-          <a:lstStyle/>
-          <a:p>
-            <a:pPr>
-              <a:lnSpc>
-                <a:spcPct val="112000"/>
-              </a:lnSpc>
-              <a:spcAft>
-                <a:spcPts val="500"/>
-              </a:spcAft>
-            </a:pPr>
-            <a:r>
-              <a:rPr sz="850" b="0">
-                <a:solidFill>
-                  <a:srgbClr val="64788A"/>
-                </a:solidFill>
-                <a:latin typeface="Noto Sans CJK SC"/>
-                <a:ea typeface="Noto Sans CJK SC"/>
-                <a:cs typeface="Noto Sans CJK SC"/>
-              </a:rPr>
-              <a:t>历史实测：2026-10-10 · 迁移前的托管部署；当前 EC2 架构见第 9 页</a:t>
-            </a:r>
-          </a:p>
-        </p:txBody>
-      </p:sp>
-      <p:sp>
-        <p:nvSpPr>
-          <p:cNvPr id="29" name="TEXT: 14 / 25"/>
+          <p:cNvPr id="28" name="TEXT: 14 / 25"/>
           <p:cNvSpPr txBox="1"/>
           <p:nvPr/>
         </p:nvSpPr>
@@ -16587,50 +16454,6 @@
       </p:cxnSp>
       <p:sp>
         <p:nvSpPr>
-          <p:cNvPr id="25" name="TEXT: 历史实测：2026-10-10 · 迁移前的托管部署；当前 EC2 架构见第 9 页"/>
-          <p:cNvSpPr txBox="1"/>
-          <p:nvPr/>
-        </p:nvSpPr>
-        <p:spPr>
-          <a:xfrm>
-            <a:off x="585216" y="6547104"/>
-            <a:ext cx="9052560" cy="192024"/>
-          </a:xfrm>
-          <a:prstGeom prst="rect">
-            <a:avLst/>
-          </a:prstGeom>
-          <a:noFill/>
-        </p:spPr>
-        <p:txBody>
-          <a:bodyPr wrap="square" lIns="13716" rIns="13716" tIns="0" bIns="0">
-            <a:spAutoFit/>
-          </a:bodyPr>
-          <a:lstStyle/>
-          <a:p>
-            <a:pPr>
-              <a:lnSpc>
-                <a:spcPct val="112000"/>
-              </a:lnSpc>
-              <a:spcAft>
-                <a:spcPts val="500"/>
-              </a:spcAft>
-            </a:pPr>
-            <a:r>
-              <a:rPr sz="850" b="0">
-                <a:solidFill>
-                  <a:srgbClr val="64788A"/>
-                </a:solidFill>
-                <a:latin typeface="Noto Sans CJK SC"/>
-                <a:ea typeface="Noto Sans CJK SC"/>
-                <a:cs typeface="Noto Sans CJK SC"/>
-              </a:rPr>
-              <a:t>历史实测：2026-10-10 · 迁移前的托管部署；当前 EC2 架构见第 9 页</a:t>
-            </a:r>
-          </a:p>
-        </p:txBody>
-      </p:sp>
-      <p:sp>
-        <p:nvSpPr>
           <p:cNvPr id="26" name="TEXT: 15 / 25"/>
           <p:cNvSpPr txBox="1"/>
           <p:nvPr/>
@@ -16984,50 +16807,6 @@
       </p:cxnSp>
       <p:sp>
         <p:nvSpPr>
-          <p:cNvPr id="9" name="TEXT: 历史实测：2026-10-10 · 迁移前的托管部署；当前 EC2 架构见第 9 页"/>
-          <p:cNvSpPr txBox="1"/>
-          <p:nvPr/>
-        </p:nvSpPr>
-        <p:spPr>
-          <a:xfrm>
-            <a:off x="585216" y="6547104"/>
-            <a:ext cx="9052560" cy="192024"/>
-          </a:xfrm>
-          <a:prstGeom prst="rect">
-            <a:avLst/>
-          </a:prstGeom>
-          <a:noFill/>
-        </p:spPr>
-        <p:txBody>
-          <a:bodyPr wrap="square" lIns="13716" rIns="13716" tIns="0" bIns="0">
-            <a:spAutoFit/>
-          </a:bodyPr>
-          <a:lstStyle/>
-          <a:p>
-            <a:pPr>
-              <a:lnSpc>
-                <a:spcPct val="112000"/>
-              </a:lnSpc>
-              <a:spcAft>
-                <a:spcPts val="500"/>
-              </a:spcAft>
-            </a:pPr>
-            <a:r>
-              <a:rPr sz="850" b="0">
-                <a:solidFill>
-                  <a:srgbClr val="64788A"/>
-                </a:solidFill>
-                <a:latin typeface="Noto Sans CJK SC"/>
-                <a:ea typeface="Noto Sans CJK SC"/>
-                <a:cs typeface="Noto Sans CJK SC"/>
-              </a:rPr>
-              <a:t>历史实测：2026-10-10 · 迁移前的托管部署；当前 EC2 架构见第 9 页</a:t>
-            </a:r>
-          </a:p>
-        </p:txBody>
-      </p:sp>
-      <p:sp>
-        <p:nvSpPr>
           <p:cNvPr id="10" name="TEXT: 16 / 25"/>
           <p:cNvSpPr txBox="1"/>
           <p:nvPr/>
@@ -18523,50 +18302,6 @@
       </p:cxnSp>
       <p:sp>
         <p:nvSpPr>
-          <p:cNvPr id="37" name="TEXT: 历史实测：2026-10-10 · 迁移前的托管部署；当前 EC2 架构见第 9 页"/>
-          <p:cNvSpPr txBox="1"/>
-          <p:nvPr/>
-        </p:nvSpPr>
-        <p:spPr>
-          <a:xfrm>
-            <a:off x="585216" y="6547104"/>
-            <a:ext cx="9052560" cy="192024"/>
-          </a:xfrm>
-          <a:prstGeom prst="rect">
-            <a:avLst/>
-          </a:prstGeom>
-          <a:noFill/>
-        </p:spPr>
-        <p:txBody>
-          <a:bodyPr wrap="square" lIns="13716" rIns="13716" tIns="0" bIns="0">
-            <a:spAutoFit/>
-          </a:bodyPr>
-          <a:lstStyle/>
-          <a:p>
-            <a:pPr>
-              <a:lnSpc>
-                <a:spcPct val="112000"/>
-              </a:lnSpc>
-              <a:spcAft>
-                <a:spcPts val="500"/>
-              </a:spcAft>
-            </a:pPr>
-            <a:r>
-              <a:rPr sz="850" b="0">
-                <a:solidFill>
-                  <a:srgbClr val="64788A"/>
-                </a:solidFill>
-                <a:latin typeface="Noto Sans CJK SC"/>
-                <a:ea typeface="Noto Sans CJK SC"/>
-                <a:cs typeface="Noto Sans CJK SC"/>
-              </a:rPr>
-              <a:t>历史实测：2026-10-10 · 迁移前的托管部署；当前 EC2 架构见第 9 页</a:t>
-            </a:r>
-          </a:p>
-        </p:txBody>
-      </p:sp>
-      <p:sp>
-        <p:nvSpPr>
           <p:cNvPr id="38" name="TEXT: 17 / 25"/>
           <p:cNvSpPr txBox="1"/>
           <p:nvPr/>
@@ -20284,50 +20019,6 @@
       </p:cxnSp>
       <p:sp>
         <p:nvSpPr>
-          <p:cNvPr id="40" name="TEXT: 历史实测：2026-10-10 · 迁移前的托管部署；当前 EC2 架构见第 9 页"/>
-          <p:cNvSpPr txBox="1"/>
-          <p:nvPr/>
-        </p:nvSpPr>
-        <p:spPr>
-          <a:xfrm>
-            <a:off x="585216" y="6547104"/>
-            <a:ext cx="9052560" cy="192024"/>
-          </a:xfrm>
-          <a:prstGeom prst="rect">
-            <a:avLst/>
-          </a:prstGeom>
-          <a:noFill/>
-        </p:spPr>
-        <p:txBody>
-          <a:bodyPr wrap="square" lIns="13716" rIns="13716" tIns="0" bIns="0">
-            <a:spAutoFit/>
-          </a:bodyPr>
-          <a:lstStyle/>
-          <a:p>
-            <a:pPr>
-              <a:lnSpc>
-                <a:spcPct val="112000"/>
-              </a:lnSpc>
-              <a:spcAft>
-                <a:spcPts val="500"/>
-              </a:spcAft>
-            </a:pPr>
-            <a:r>
-              <a:rPr sz="850" b="0">
-                <a:solidFill>
-                  <a:srgbClr val="64788A"/>
-                </a:solidFill>
-                <a:latin typeface="Noto Sans CJK SC"/>
-                <a:ea typeface="Noto Sans CJK SC"/>
-                <a:cs typeface="Noto Sans CJK SC"/>
-              </a:rPr>
-              <a:t>历史实测：2026-10-10 · 迁移前的托管部署；当前 EC2 架构见第 9 页</a:t>
-            </a:r>
-          </a:p>
-        </p:txBody>
-      </p:sp>
-      <p:sp>
-        <p:nvSpPr>
           <p:cNvPr id="41" name="TEXT: 18 / 25"/>
           <p:cNvSpPr txBox="1"/>
           <p:nvPr/>
@@ -21057,50 +20748,6 @@
       </p:cxnSp>
       <p:sp>
         <p:nvSpPr>
-          <p:cNvPr id="17" name="TEXT: 历史实测：2026-10-10 · 迁移前的托管部署；当前 EC2 架构见第 9 页"/>
-          <p:cNvSpPr txBox="1"/>
-          <p:nvPr/>
-        </p:nvSpPr>
-        <p:spPr>
-          <a:xfrm>
-            <a:off x="585216" y="6547104"/>
-            <a:ext cx="9052560" cy="192024"/>
-          </a:xfrm>
-          <a:prstGeom prst="rect">
-            <a:avLst/>
-          </a:prstGeom>
-          <a:noFill/>
-        </p:spPr>
-        <p:txBody>
-          <a:bodyPr wrap="square" lIns="13716" rIns="13716" tIns="0" bIns="0">
-            <a:spAutoFit/>
-          </a:bodyPr>
-          <a:lstStyle/>
-          <a:p>
-            <a:pPr>
-              <a:lnSpc>
-                <a:spcPct val="112000"/>
-              </a:lnSpc>
-              <a:spcAft>
-                <a:spcPts val="500"/>
-              </a:spcAft>
-            </a:pPr>
-            <a:r>
-              <a:rPr sz="850" b="0">
-                <a:solidFill>
-                  <a:srgbClr val="8CA6BF"/>
-                </a:solidFill>
-                <a:latin typeface="Noto Sans CJK SC"/>
-                <a:ea typeface="Noto Sans CJK SC"/>
-                <a:cs typeface="Noto Sans CJK SC"/>
-              </a:rPr>
-              <a:t>历史实测：2026-10-10 · 迁移前的托管部署；当前 EC2 架构见第 9 页</a:t>
-            </a:r>
-          </a:p>
-        </p:txBody>
-      </p:sp>
-      <p:sp>
-        <p:nvSpPr>
           <p:cNvPr id="18" name="TEXT: 19 / 25"/>
           <p:cNvSpPr txBox="1"/>
           <p:nvPr/>
@@ -24107,50 +23754,6 @@
       </p:cxnSp>
       <p:sp>
         <p:nvSpPr>
-          <p:cNvPr id="39" name="TEXT: 历史实测：2026-10-10 · 迁移前的托管部署；当前 EC2 架构见第 9 页"/>
-          <p:cNvSpPr txBox="1"/>
-          <p:nvPr/>
-        </p:nvSpPr>
-        <p:spPr>
-          <a:xfrm>
-            <a:off x="585216" y="6547104"/>
-            <a:ext cx="9052560" cy="192024"/>
-          </a:xfrm>
-          <a:prstGeom prst="rect">
-            <a:avLst/>
-          </a:prstGeom>
-          <a:noFill/>
-        </p:spPr>
-        <p:txBody>
-          <a:bodyPr wrap="square" lIns="13716" rIns="13716" tIns="0" bIns="0">
-            <a:spAutoFit/>
-          </a:bodyPr>
-          <a:lstStyle/>
-          <a:p>
-            <a:pPr>
-              <a:lnSpc>
-                <a:spcPct val="112000"/>
-              </a:lnSpc>
-              <a:spcAft>
-                <a:spcPts val="500"/>
-              </a:spcAft>
-            </a:pPr>
-            <a:r>
-              <a:rPr sz="850" b="0">
-                <a:solidFill>
-                  <a:srgbClr val="64788A"/>
-                </a:solidFill>
-                <a:latin typeface="Noto Sans CJK SC"/>
-                <a:ea typeface="Noto Sans CJK SC"/>
-                <a:cs typeface="Noto Sans CJK SC"/>
-              </a:rPr>
-              <a:t>历史实测：2026-10-10 · 迁移前的托管部署；当前 EC2 架构见第 9 页</a:t>
-            </a:r>
-          </a:p>
-        </p:txBody>
-      </p:sp>
-      <p:sp>
-        <p:nvSpPr>
           <p:cNvPr id="40" name="TEXT: 20 / 25"/>
           <p:cNvSpPr txBox="1"/>
           <p:nvPr/>
@@ -26192,50 +25795,6 @@
       </p:cxnSp>
       <p:sp>
         <p:nvSpPr>
-          <p:cNvPr id="46" name="TEXT: 历史实测：2026-10-10 · 迁移前的托管部署；当前 EC2 架构见第 9 页"/>
-          <p:cNvSpPr txBox="1"/>
-          <p:nvPr/>
-        </p:nvSpPr>
-        <p:spPr>
-          <a:xfrm>
-            <a:off x="585216" y="6547104"/>
-            <a:ext cx="9052560" cy="192024"/>
-          </a:xfrm>
-          <a:prstGeom prst="rect">
-            <a:avLst/>
-          </a:prstGeom>
-          <a:noFill/>
-        </p:spPr>
-        <p:txBody>
-          <a:bodyPr wrap="square" lIns="13716" rIns="13716" tIns="0" bIns="0">
-            <a:spAutoFit/>
-          </a:bodyPr>
-          <a:lstStyle/>
-          <a:p>
-            <a:pPr>
-              <a:lnSpc>
-                <a:spcPct val="112000"/>
-              </a:lnSpc>
-              <a:spcAft>
-                <a:spcPts val="500"/>
-              </a:spcAft>
-            </a:pPr>
-            <a:r>
-              <a:rPr sz="850" b="0">
-                <a:solidFill>
-                  <a:srgbClr val="64788A"/>
-                </a:solidFill>
-                <a:latin typeface="Noto Sans CJK SC"/>
-                <a:ea typeface="Noto Sans CJK SC"/>
-                <a:cs typeface="Noto Sans CJK SC"/>
-              </a:rPr>
-              <a:t>历史实测：2026-10-10 · 迁移前的托管部署；当前 EC2 架构见第 9 页</a:t>
-            </a:r>
-          </a:p>
-        </p:txBody>
-      </p:sp>
-      <p:sp>
-        <p:nvSpPr>
           <p:cNvPr id="47" name="TEXT: 21 / 25"/>
           <p:cNvSpPr txBox="1"/>
           <p:nvPr/>
@@ -28537,50 +28096,6 @@
       </p:cxnSp>
       <p:sp>
         <p:nvSpPr>
-          <p:cNvPr id="50" name="TEXT: 历史实测：2026-10-10 · 迁移前的托管部署；当前 EC2 架构见第 9 页"/>
-          <p:cNvSpPr txBox="1"/>
-          <p:nvPr/>
-        </p:nvSpPr>
-        <p:spPr>
-          <a:xfrm>
-            <a:off x="585216" y="6547104"/>
-            <a:ext cx="9052560" cy="192024"/>
-          </a:xfrm>
-          <a:prstGeom prst="rect">
-            <a:avLst/>
-          </a:prstGeom>
-          <a:noFill/>
-        </p:spPr>
-        <p:txBody>
-          <a:bodyPr wrap="square" lIns="13716" rIns="13716" tIns="0" bIns="0">
-            <a:spAutoFit/>
-          </a:bodyPr>
-          <a:lstStyle/>
-          <a:p>
-            <a:pPr>
-              <a:lnSpc>
-                <a:spcPct val="112000"/>
-              </a:lnSpc>
-              <a:spcAft>
-                <a:spcPts val="500"/>
-              </a:spcAft>
-            </a:pPr>
-            <a:r>
-              <a:rPr sz="850" b="0">
-                <a:solidFill>
-                  <a:srgbClr val="64788A"/>
-                </a:solidFill>
-                <a:latin typeface="Noto Sans CJK SC"/>
-                <a:ea typeface="Noto Sans CJK SC"/>
-                <a:cs typeface="Noto Sans CJK SC"/>
-              </a:rPr>
-              <a:t>历史实测：2026-10-10 · 迁移前的托管部署；当前 EC2 架构见第 9 页</a:t>
-            </a:r>
-          </a:p>
-        </p:txBody>
-      </p:sp>
-      <p:sp>
-        <p:nvSpPr>
           <p:cNvPr id="51" name="TEXT: 22 / 25"/>
           <p:cNvSpPr txBox="1"/>
           <p:nvPr/>
@@ -30652,50 +30167,6 @@
           </a:fontRef>
         </p:style>
       </p:cxnSp>
-      <p:sp>
-        <p:nvSpPr>
-          <p:cNvPr id="16" name="TEXT: 历史实测：2026-10-10 · 迁移前的托管部署；当前 EC2 架构见第 9 页"/>
-          <p:cNvSpPr txBox="1"/>
-          <p:nvPr/>
-        </p:nvSpPr>
-        <p:spPr>
-          <a:xfrm>
-            <a:off x="585216" y="6547104"/>
-            <a:ext cx="9052560" cy="192024"/>
-          </a:xfrm>
-          <a:prstGeom prst="rect">
-            <a:avLst/>
-          </a:prstGeom>
-          <a:noFill/>
-        </p:spPr>
-        <p:txBody>
-          <a:bodyPr wrap="square" lIns="13716" rIns="13716" tIns="0" bIns="0">
-            <a:spAutoFit/>
-          </a:bodyPr>
-          <a:lstStyle/>
-          <a:p>
-            <a:pPr>
-              <a:lnSpc>
-                <a:spcPct val="112000"/>
-              </a:lnSpc>
-              <a:spcAft>
-                <a:spcPts val="500"/>
-              </a:spcAft>
-            </a:pPr>
-            <a:r>
-              <a:rPr sz="850" b="0">
-                <a:solidFill>
-                  <a:srgbClr val="8CA6BF"/>
-                </a:solidFill>
-                <a:latin typeface="Noto Sans CJK SC"/>
-                <a:ea typeface="Noto Sans CJK SC"/>
-                <a:cs typeface="Noto Sans CJK SC"/>
-              </a:rPr>
-              <a:t>历史实测：2026-10-10 · 迁移前的托管部署；当前 EC2 架构见第 9 页</a:t>
-            </a:r>
-          </a:p>
-        </p:txBody>
-      </p:sp>
       <p:sp>
         <p:nvSpPr>
           <p:cNvPr id="17" name="TEXT: 24 / 25"/>

</xml_diff>